<commit_message>
Show dynamic products on frontend
</commit_message>
<xml_diff>
--- a/.lessons/36 Packages Shopping Cart/2 Show dynamic products on frontend/1.pptx
+++ b/.lessons/36 Packages Shopping Cart/2 Show dynamic products on frontend/1.pptx
@@ -8,6 +8,10 @@
     <p:sldId id="402" r:id="rId2"/>
     <p:sldId id="403" r:id="rId3"/>
     <p:sldId id="400" r:id="rId4"/>
+    <p:sldId id="404" r:id="rId5"/>
+    <p:sldId id="405" r:id="rId6"/>
+    <p:sldId id="406" r:id="rId7"/>
+    <p:sldId id="407" r:id="rId8"/>
   </p:sldIdLst>
   <p:sldSz cx="12192000" cy="6858000"/>
   <p:notesSz cx="6858000" cy="9144000"/>
@@ -261,7 +265,7 @@
           <a:p>
             <a:fld id="{3E102D2E-813C-461C-9963-687A650C48C0}" type="datetimeFigureOut">
               <a:rPr lang="en-US" smtClean="0"/>
-              <a:t>5/23/2025</a:t>
+              <a:t>6/18/2025</a:t>
             </a:fld>
             <a:endParaRPr lang="en-US"/>
           </a:p>
@@ -459,7 +463,7 @@
           <a:p>
             <a:fld id="{3E102D2E-813C-461C-9963-687A650C48C0}" type="datetimeFigureOut">
               <a:rPr lang="en-US" smtClean="0"/>
-              <a:t>5/23/2025</a:t>
+              <a:t>6/18/2025</a:t>
             </a:fld>
             <a:endParaRPr lang="en-US"/>
           </a:p>
@@ -667,7 +671,7 @@
           <a:p>
             <a:fld id="{3E102D2E-813C-461C-9963-687A650C48C0}" type="datetimeFigureOut">
               <a:rPr lang="en-US" smtClean="0"/>
-              <a:t>5/23/2025</a:t>
+              <a:t>6/18/2025</a:t>
             </a:fld>
             <a:endParaRPr lang="en-US"/>
           </a:p>
@@ -865,7 +869,7 @@
           <a:p>
             <a:fld id="{3E102D2E-813C-461C-9963-687A650C48C0}" type="datetimeFigureOut">
               <a:rPr lang="en-US" smtClean="0"/>
-              <a:t>5/23/2025</a:t>
+              <a:t>6/18/2025</a:t>
             </a:fld>
             <a:endParaRPr lang="en-US"/>
           </a:p>
@@ -1140,7 +1144,7 @@
           <a:p>
             <a:fld id="{3E102D2E-813C-461C-9963-687A650C48C0}" type="datetimeFigureOut">
               <a:rPr lang="en-US" smtClean="0"/>
-              <a:t>5/23/2025</a:t>
+              <a:t>6/18/2025</a:t>
             </a:fld>
             <a:endParaRPr lang="en-US"/>
           </a:p>
@@ -1405,7 +1409,7 @@
           <a:p>
             <a:fld id="{3E102D2E-813C-461C-9963-687A650C48C0}" type="datetimeFigureOut">
               <a:rPr lang="en-US" smtClean="0"/>
-              <a:t>5/23/2025</a:t>
+              <a:t>6/18/2025</a:t>
             </a:fld>
             <a:endParaRPr lang="en-US"/>
           </a:p>
@@ -1817,7 +1821,7 @@
           <a:p>
             <a:fld id="{3E102D2E-813C-461C-9963-687A650C48C0}" type="datetimeFigureOut">
               <a:rPr lang="en-US" smtClean="0"/>
-              <a:t>5/23/2025</a:t>
+              <a:t>6/18/2025</a:t>
             </a:fld>
             <a:endParaRPr lang="en-US"/>
           </a:p>
@@ -1958,7 +1962,7 @@
           <a:p>
             <a:fld id="{3E102D2E-813C-461C-9963-687A650C48C0}" type="datetimeFigureOut">
               <a:rPr lang="en-US" smtClean="0"/>
-              <a:t>5/23/2025</a:t>
+              <a:t>6/18/2025</a:t>
             </a:fld>
             <a:endParaRPr lang="en-US"/>
           </a:p>
@@ -2071,7 +2075,7 @@
           <a:p>
             <a:fld id="{3E102D2E-813C-461C-9963-687A650C48C0}" type="datetimeFigureOut">
               <a:rPr lang="en-US" smtClean="0"/>
-              <a:t>5/23/2025</a:t>
+              <a:t>6/18/2025</a:t>
             </a:fld>
             <a:endParaRPr lang="en-US"/>
           </a:p>
@@ -2382,7 +2386,7 @@
           <a:p>
             <a:fld id="{3E102D2E-813C-461C-9963-687A650C48C0}" type="datetimeFigureOut">
               <a:rPr lang="en-US" smtClean="0"/>
-              <a:t>5/23/2025</a:t>
+              <a:t>6/18/2025</a:t>
             </a:fld>
             <a:endParaRPr lang="en-US"/>
           </a:p>
@@ -2670,7 +2674,7 @@
           <a:p>
             <a:fld id="{3E102D2E-813C-461C-9963-687A650C48C0}" type="datetimeFigureOut">
               <a:rPr lang="en-US" smtClean="0"/>
-              <a:t>5/23/2025</a:t>
+              <a:t>6/18/2025</a:t>
             </a:fld>
             <a:endParaRPr lang="en-US"/>
           </a:p>
@@ -2911,7 +2915,7 @@
           <a:p>
             <a:fld id="{3E102D2E-813C-461C-9963-687A650C48C0}" type="datetimeFigureOut">
               <a:rPr lang="en-US" smtClean="0"/>
-              <a:t>5/23/2025</a:t>
+              <a:t>6/18/2025</a:t>
             </a:fld>
             <a:endParaRPr lang="en-US"/>
           </a:p>
@@ -3369,7 +3373,7 @@
               <a:buNone/>
             </a:pPr>
             <a:r>
-              <a:rPr kumimoji="0" lang="en-US" altLang="en-US" sz="1300" b="0" i="0" u="none" strike="noStrike" cap="none" normalizeH="0" baseline="0">
+              <a:rPr kumimoji="0" lang="az-Latn-AZ" altLang="en-US" sz="1300" b="1" i="0" u="none" strike="noStrike" cap="none" normalizeH="0" baseline="0">
                 <a:ln>
                   <a:noFill/>
                 </a:ln>
@@ -3379,11 +3383,90 @@
                 <a:effectLst/>
                 <a:latin typeface="Arial" panose="020B0604020202020204" pitchFamily="34" charset="0"/>
               </a:rPr>
-              <a:t>.</a:t>
-            </a:r>
-          </a:p>
-        </p:txBody>
-      </p:sp>
+              <a:t>Route</a:t>
+            </a:r>
+            <a:r>
+              <a:rPr kumimoji="0" lang="az-Latn-AZ" altLang="en-US" sz="1300" b="0" i="0" u="none" strike="noStrike" cap="none" normalizeH="0" baseline="0">
+                <a:ln>
+                  <a:noFill/>
+                </a:ln>
+                <a:solidFill>
+                  <a:schemeClr val="tx1"/>
+                </a:solidFill>
+                <a:effectLst/>
+                <a:latin typeface="Arial" panose="020B0604020202020204" pitchFamily="34" charset="0"/>
+              </a:rPr>
+              <a:t> -lar üçün </a:t>
+            </a:r>
+            <a:r>
+              <a:rPr kumimoji="0" lang="az-Latn-AZ" altLang="en-US" sz="1300" b="1" i="0" u="none" strike="noStrike" cap="none" normalizeH="0" baseline="0">
+                <a:ln>
+                  <a:noFill/>
+                </a:ln>
+                <a:solidFill>
+                  <a:schemeClr val="tx1"/>
+                </a:solidFill>
+                <a:effectLst/>
+                <a:latin typeface="Arial" panose="020B0604020202020204" pitchFamily="34" charset="0"/>
+              </a:rPr>
+              <a:t>CartController</a:t>
+            </a:r>
+            <a:r>
+              <a:rPr kumimoji="0" lang="az-Latn-AZ" altLang="en-US" sz="1300" b="0" i="0" u="none" strike="noStrike" cap="none" normalizeH="0" baseline="0">
+                <a:ln>
+                  <a:noFill/>
+                </a:ln>
+                <a:solidFill>
+                  <a:schemeClr val="tx1"/>
+                </a:solidFill>
+                <a:effectLst/>
+                <a:latin typeface="Arial" panose="020B0604020202020204" pitchFamily="34" charset="0"/>
+              </a:rPr>
+              <a:t> adında kontroller yaradırıq. </a:t>
+            </a:r>
+            <a:endParaRPr kumimoji="0" lang="en-US" altLang="en-US" sz="1300" b="0" i="0" u="none" strike="noStrike" cap="none" normalizeH="0" baseline="0">
+              <a:ln>
+                <a:noFill/>
+              </a:ln>
+              <a:solidFill>
+                <a:schemeClr val="tx1"/>
+              </a:solidFill>
+              <a:effectLst/>
+              <a:latin typeface="Arial" panose="020B0604020202020204" pitchFamily="34" charset="0"/>
+            </a:endParaRPr>
+          </a:p>
+        </p:txBody>
+      </p:sp>
+      <p:pic>
+        <p:nvPicPr>
+          <p:cNvPr id="4" name="Picture 3">
+            <a:extLst>
+              <a:ext uri="{FF2B5EF4-FFF2-40B4-BE49-F238E27FC236}">
+                <a16:creationId xmlns:a16="http://schemas.microsoft.com/office/drawing/2014/main" id="{1D8B29F5-1CCC-006D-4A4D-B65029AB58BF}"/>
+              </a:ext>
+            </a:extLst>
+          </p:cNvPr>
+          <p:cNvPicPr>
+            <a:picLocks noChangeAspect="1"/>
+          </p:cNvPicPr>
+          <p:nvPr/>
+        </p:nvPicPr>
+        <p:blipFill>
+          <a:blip r:embed="rId2"/>
+          <a:stretch>
+            <a:fillRect/>
+          </a:stretch>
+        </p:blipFill>
+        <p:spPr>
+          <a:xfrm>
+            <a:off x="-1" y="1553927"/>
+            <a:ext cx="12192000" cy="5304073"/>
+          </a:xfrm>
+          <a:prstGeom prst="rect">
+            <a:avLst/>
+          </a:prstGeom>
+        </p:spPr>
+      </p:pic>
     </p:spTree>
     <p:extLst>
       <p:ext uri="{BB962C8B-B14F-4D97-AF65-F5344CB8AC3E}">
@@ -3455,7 +3538,7 @@
               <a:buNone/>
             </a:pPr>
             <a:r>
-              <a:rPr kumimoji="0" lang="en-US" altLang="en-US" sz="1300" b="0" i="0" u="none" strike="noStrike" cap="none" normalizeH="0" baseline="0">
+              <a:rPr kumimoji="0" lang="az-Latn-AZ" altLang="en-US" sz="1300" b="0" i="0" u="none" strike="noStrike" cap="none" normalizeH="0" baseline="0">
                 <a:ln>
                   <a:noFill/>
                 </a:ln>
@@ -3465,11 +3548,51 @@
                 <a:effectLst/>
                 <a:latin typeface="Arial" panose="020B0604020202020204" pitchFamily="34" charset="0"/>
               </a:rPr>
-              <a:t>.</a:t>
-            </a:r>
-          </a:p>
-        </p:txBody>
-      </p:sp>
+              <a:t>Məıumatlar DB -dən çəkərək şablona göndəririk.</a:t>
+            </a:r>
+            <a:endParaRPr kumimoji="0" lang="en-US" altLang="en-US" sz="1300" b="0" i="0" u="none" strike="noStrike" cap="none" normalizeH="0" baseline="0">
+              <a:ln>
+                <a:noFill/>
+              </a:ln>
+              <a:solidFill>
+                <a:schemeClr val="tx1"/>
+              </a:solidFill>
+              <a:effectLst/>
+              <a:latin typeface="Arial" panose="020B0604020202020204" pitchFamily="34" charset="0"/>
+            </a:endParaRPr>
+          </a:p>
+        </p:txBody>
+      </p:sp>
+      <p:pic>
+        <p:nvPicPr>
+          <p:cNvPr id="4" name="Picture 3">
+            <a:extLst>
+              <a:ext uri="{FF2B5EF4-FFF2-40B4-BE49-F238E27FC236}">
+                <a16:creationId xmlns:a16="http://schemas.microsoft.com/office/drawing/2014/main" id="{4C0D7DBE-453F-77DE-9063-99E91160E73A}"/>
+              </a:ext>
+            </a:extLst>
+          </p:cNvPr>
+          <p:cNvPicPr>
+            <a:picLocks noChangeAspect="1"/>
+          </p:cNvPicPr>
+          <p:nvPr/>
+        </p:nvPicPr>
+        <p:blipFill>
+          <a:blip r:embed="rId2"/>
+          <a:stretch>
+            <a:fillRect/>
+          </a:stretch>
+        </p:blipFill>
+        <p:spPr>
+          <a:xfrm>
+            <a:off x="1987420" y="1421856"/>
+            <a:ext cx="10204580" cy="5436143"/>
+          </a:xfrm>
+          <a:prstGeom prst="rect">
+            <a:avLst/>
+          </a:prstGeom>
+        </p:spPr>
+      </p:pic>
     </p:spTree>
     <p:extLst>
       <p:ext uri="{BB962C8B-B14F-4D97-AF65-F5344CB8AC3E}">
@@ -3560,6 +3683,350 @@
     <p:extLst>
       <p:ext uri="{BB962C8B-B14F-4D97-AF65-F5344CB8AC3E}">
         <p14:creationId xmlns:p14="http://schemas.microsoft.com/office/powerpoint/2010/main" val="3095838342"/>
+      </p:ext>
+    </p:extLst>
+  </p:cSld>
+  <p:clrMapOvr>
+    <a:masterClrMapping/>
+  </p:clrMapOvr>
+</p:sld>
+</file>
+
+<file path=ppt/slides/slide4.xml><?xml version="1.0" encoding="utf-8"?>
+<p:sld xmlns:a="http://schemas.openxmlformats.org/drawingml/2006/main" xmlns:r="http://schemas.openxmlformats.org/officeDocument/2006/relationships" xmlns:p="http://schemas.openxmlformats.org/presentationml/2006/main">
+  <p:cSld>
+    <p:spTree>
+      <p:nvGrpSpPr>
+        <p:cNvPr id="1" name="">
+          <a:extLst>
+            <a:ext uri="{FF2B5EF4-FFF2-40B4-BE49-F238E27FC236}">
+              <a16:creationId xmlns:a16="http://schemas.microsoft.com/office/drawing/2014/main" id="{3352238F-D25E-979A-A657-222F997F24EA}"/>
+            </a:ext>
+          </a:extLst>
+        </p:cNvPr>
+        <p:cNvGrpSpPr/>
+        <p:nvPr/>
+      </p:nvGrpSpPr>
+      <p:grpSpPr>
+        <a:xfrm>
+          <a:off x="0" y="0"/>
+          <a:ext cx="0" cy="0"/>
+          <a:chOff x="0" y="0"/>
+          <a:chExt cx="0" cy="0"/>
+        </a:xfrm>
+      </p:grpSpPr>
+      <p:sp>
+        <p:nvSpPr>
+          <p:cNvPr id="3" name="TextBox 2">
+            <a:extLst>
+              <a:ext uri="{FF2B5EF4-FFF2-40B4-BE49-F238E27FC236}">
+                <a16:creationId xmlns:a16="http://schemas.microsoft.com/office/drawing/2014/main" id="{D7DCE99C-2C42-1589-E05E-DB3D5D020135}"/>
+              </a:ext>
+            </a:extLst>
+          </p:cNvPr>
+          <p:cNvSpPr txBox="1"/>
+          <p:nvPr/>
+        </p:nvSpPr>
+        <p:spPr>
+          <a:xfrm>
+            <a:off x="217714" y="255046"/>
+            <a:ext cx="11756571" cy="355354"/>
+          </a:xfrm>
+          <a:prstGeom prst="rect">
+            <a:avLst/>
+          </a:prstGeom>
+          <a:noFill/>
+        </p:spPr>
+        <p:txBody>
+          <a:bodyPr wrap="square">
+            <a:spAutoFit/>
+          </a:bodyPr>
+          <a:lstStyle/>
+          <a:p>
+            <a:pPr>
+              <a:lnSpc>
+                <a:spcPct val="150000"/>
+              </a:lnSpc>
+              <a:buNone/>
+            </a:pPr>
+            <a:r>
+              <a:rPr kumimoji="0" lang="en-US" altLang="en-US" sz="1300" b="0" i="0" u="none" strike="noStrike" cap="none" normalizeH="0" baseline="0">
+                <a:ln>
+                  <a:noFill/>
+                </a:ln>
+                <a:solidFill>
+                  <a:schemeClr val="tx1"/>
+                </a:solidFill>
+                <a:effectLst/>
+                <a:latin typeface="Arial" panose="020B0604020202020204" pitchFamily="34" charset="0"/>
+              </a:rPr>
+              <a:t>.</a:t>
+            </a:r>
+          </a:p>
+        </p:txBody>
+      </p:sp>
+    </p:spTree>
+    <p:extLst>
+      <p:ext uri="{BB962C8B-B14F-4D97-AF65-F5344CB8AC3E}">
+        <p14:creationId xmlns:p14="http://schemas.microsoft.com/office/powerpoint/2010/main" val="1758668488"/>
+      </p:ext>
+    </p:extLst>
+  </p:cSld>
+  <p:clrMapOvr>
+    <a:masterClrMapping/>
+  </p:clrMapOvr>
+</p:sld>
+</file>
+
+<file path=ppt/slides/slide5.xml><?xml version="1.0" encoding="utf-8"?>
+<p:sld xmlns:a="http://schemas.openxmlformats.org/drawingml/2006/main" xmlns:r="http://schemas.openxmlformats.org/officeDocument/2006/relationships" xmlns:p="http://schemas.openxmlformats.org/presentationml/2006/main">
+  <p:cSld>
+    <p:spTree>
+      <p:nvGrpSpPr>
+        <p:cNvPr id="1" name="">
+          <a:extLst>
+            <a:ext uri="{FF2B5EF4-FFF2-40B4-BE49-F238E27FC236}">
+              <a16:creationId xmlns:a16="http://schemas.microsoft.com/office/drawing/2014/main" id="{537DA49B-D71E-20AB-8385-7D5433C5FAB6}"/>
+            </a:ext>
+          </a:extLst>
+        </p:cNvPr>
+        <p:cNvGrpSpPr/>
+        <p:nvPr/>
+      </p:nvGrpSpPr>
+      <p:grpSpPr>
+        <a:xfrm>
+          <a:off x="0" y="0"/>
+          <a:ext cx="0" cy="0"/>
+          <a:chOff x="0" y="0"/>
+          <a:chExt cx="0" cy="0"/>
+        </a:xfrm>
+      </p:grpSpPr>
+      <p:sp>
+        <p:nvSpPr>
+          <p:cNvPr id="3" name="TextBox 2">
+            <a:extLst>
+              <a:ext uri="{FF2B5EF4-FFF2-40B4-BE49-F238E27FC236}">
+                <a16:creationId xmlns:a16="http://schemas.microsoft.com/office/drawing/2014/main" id="{803CD830-35A5-CE86-CC86-BEB4938DFBE7}"/>
+              </a:ext>
+            </a:extLst>
+          </p:cNvPr>
+          <p:cNvSpPr txBox="1"/>
+          <p:nvPr/>
+        </p:nvSpPr>
+        <p:spPr>
+          <a:xfrm>
+            <a:off x="217714" y="255046"/>
+            <a:ext cx="11756571" cy="355354"/>
+          </a:xfrm>
+          <a:prstGeom prst="rect">
+            <a:avLst/>
+          </a:prstGeom>
+          <a:noFill/>
+        </p:spPr>
+        <p:txBody>
+          <a:bodyPr wrap="square">
+            <a:spAutoFit/>
+          </a:bodyPr>
+          <a:lstStyle/>
+          <a:p>
+            <a:pPr>
+              <a:lnSpc>
+                <a:spcPct val="150000"/>
+              </a:lnSpc>
+              <a:buNone/>
+            </a:pPr>
+            <a:r>
+              <a:rPr kumimoji="0" lang="en-US" altLang="en-US" sz="1300" b="0" i="0" u="none" strike="noStrike" cap="none" normalizeH="0" baseline="0">
+                <a:ln>
+                  <a:noFill/>
+                </a:ln>
+                <a:solidFill>
+                  <a:schemeClr val="tx1"/>
+                </a:solidFill>
+                <a:effectLst/>
+                <a:latin typeface="Arial" panose="020B0604020202020204" pitchFamily="34" charset="0"/>
+              </a:rPr>
+              <a:t>.</a:t>
+            </a:r>
+          </a:p>
+        </p:txBody>
+      </p:sp>
+    </p:spTree>
+    <p:extLst>
+      <p:ext uri="{BB962C8B-B14F-4D97-AF65-F5344CB8AC3E}">
+        <p14:creationId xmlns:p14="http://schemas.microsoft.com/office/powerpoint/2010/main" val="1747902460"/>
+      </p:ext>
+    </p:extLst>
+  </p:cSld>
+  <p:clrMapOvr>
+    <a:masterClrMapping/>
+  </p:clrMapOvr>
+</p:sld>
+</file>
+
+<file path=ppt/slides/slide6.xml><?xml version="1.0" encoding="utf-8"?>
+<p:sld xmlns:a="http://schemas.openxmlformats.org/drawingml/2006/main" xmlns:r="http://schemas.openxmlformats.org/officeDocument/2006/relationships" xmlns:p="http://schemas.openxmlformats.org/presentationml/2006/main">
+  <p:cSld>
+    <p:spTree>
+      <p:nvGrpSpPr>
+        <p:cNvPr id="1" name="">
+          <a:extLst>
+            <a:ext uri="{FF2B5EF4-FFF2-40B4-BE49-F238E27FC236}">
+              <a16:creationId xmlns:a16="http://schemas.microsoft.com/office/drawing/2014/main" id="{F9D4EAA6-9F6A-F6B5-B822-35B3D492516D}"/>
+            </a:ext>
+          </a:extLst>
+        </p:cNvPr>
+        <p:cNvGrpSpPr/>
+        <p:nvPr/>
+      </p:nvGrpSpPr>
+      <p:grpSpPr>
+        <a:xfrm>
+          <a:off x="0" y="0"/>
+          <a:ext cx="0" cy="0"/>
+          <a:chOff x="0" y="0"/>
+          <a:chExt cx="0" cy="0"/>
+        </a:xfrm>
+      </p:grpSpPr>
+      <p:sp>
+        <p:nvSpPr>
+          <p:cNvPr id="3" name="TextBox 2">
+            <a:extLst>
+              <a:ext uri="{FF2B5EF4-FFF2-40B4-BE49-F238E27FC236}">
+                <a16:creationId xmlns:a16="http://schemas.microsoft.com/office/drawing/2014/main" id="{E6CB9A1D-D02D-245C-6A70-95CB1B5D2AB3}"/>
+              </a:ext>
+            </a:extLst>
+          </p:cNvPr>
+          <p:cNvSpPr txBox="1"/>
+          <p:nvPr/>
+        </p:nvSpPr>
+        <p:spPr>
+          <a:xfrm>
+            <a:off x="217714" y="255046"/>
+            <a:ext cx="11756571" cy="355354"/>
+          </a:xfrm>
+          <a:prstGeom prst="rect">
+            <a:avLst/>
+          </a:prstGeom>
+          <a:noFill/>
+        </p:spPr>
+        <p:txBody>
+          <a:bodyPr wrap="square">
+            <a:spAutoFit/>
+          </a:bodyPr>
+          <a:lstStyle/>
+          <a:p>
+            <a:pPr>
+              <a:lnSpc>
+                <a:spcPct val="150000"/>
+              </a:lnSpc>
+              <a:buNone/>
+            </a:pPr>
+            <a:r>
+              <a:rPr kumimoji="0" lang="en-US" altLang="en-US" sz="1300" b="0" i="0" u="none" strike="noStrike" cap="none" normalizeH="0" baseline="0">
+                <a:ln>
+                  <a:noFill/>
+                </a:ln>
+                <a:solidFill>
+                  <a:schemeClr val="tx1"/>
+                </a:solidFill>
+                <a:effectLst/>
+                <a:latin typeface="Arial" panose="020B0604020202020204" pitchFamily="34" charset="0"/>
+              </a:rPr>
+              <a:t>.</a:t>
+            </a:r>
+          </a:p>
+        </p:txBody>
+      </p:sp>
+    </p:spTree>
+    <p:extLst>
+      <p:ext uri="{BB962C8B-B14F-4D97-AF65-F5344CB8AC3E}">
+        <p14:creationId xmlns:p14="http://schemas.microsoft.com/office/powerpoint/2010/main" val="786245423"/>
+      </p:ext>
+    </p:extLst>
+  </p:cSld>
+  <p:clrMapOvr>
+    <a:masterClrMapping/>
+  </p:clrMapOvr>
+</p:sld>
+</file>
+
+<file path=ppt/slides/slide7.xml><?xml version="1.0" encoding="utf-8"?>
+<p:sld xmlns:a="http://schemas.openxmlformats.org/drawingml/2006/main" xmlns:r="http://schemas.openxmlformats.org/officeDocument/2006/relationships" xmlns:p="http://schemas.openxmlformats.org/presentationml/2006/main">
+  <p:cSld>
+    <p:spTree>
+      <p:nvGrpSpPr>
+        <p:cNvPr id="1" name="">
+          <a:extLst>
+            <a:ext uri="{FF2B5EF4-FFF2-40B4-BE49-F238E27FC236}">
+              <a16:creationId xmlns:a16="http://schemas.microsoft.com/office/drawing/2014/main" id="{BC9AE542-C8BE-0F73-AE11-D0D8246C0DE1}"/>
+            </a:ext>
+          </a:extLst>
+        </p:cNvPr>
+        <p:cNvGrpSpPr/>
+        <p:nvPr/>
+      </p:nvGrpSpPr>
+      <p:grpSpPr>
+        <a:xfrm>
+          <a:off x="0" y="0"/>
+          <a:ext cx="0" cy="0"/>
+          <a:chOff x="0" y="0"/>
+          <a:chExt cx="0" cy="0"/>
+        </a:xfrm>
+      </p:grpSpPr>
+      <p:sp>
+        <p:nvSpPr>
+          <p:cNvPr id="3" name="TextBox 2">
+            <a:extLst>
+              <a:ext uri="{FF2B5EF4-FFF2-40B4-BE49-F238E27FC236}">
+                <a16:creationId xmlns:a16="http://schemas.microsoft.com/office/drawing/2014/main" id="{90071B32-9164-3615-5605-0B748C2C6716}"/>
+              </a:ext>
+            </a:extLst>
+          </p:cNvPr>
+          <p:cNvSpPr txBox="1"/>
+          <p:nvPr/>
+        </p:nvSpPr>
+        <p:spPr>
+          <a:xfrm>
+            <a:off x="217714" y="255046"/>
+            <a:ext cx="11756571" cy="355354"/>
+          </a:xfrm>
+          <a:prstGeom prst="rect">
+            <a:avLst/>
+          </a:prstGeom>
+          <a:noFill/>
+        </p:spPr>
+        <p:txBody>
+          <a:bodyPr wrap="square">
+            <a:spAutoFit/>
+          </a:bodyPr>
+          <a:lstStyle/>
+          <a:p>
+            <a:pPr>
+              <a:lnSpc>
+                <a:spcPct val="150000"/>
+              </a:lnSpc>
+              <a:buNone/>
+            </a:pPr>
+            <a:r>
+              <a:rPr kumimoji="0" lang="en-US" altLang="en-US" sz="1300" b="0" i="0" u="none" strike="noStrike" cap="none" normalizeH="0" baseline="0">
+                <a:ln>
+                  <a:noFill/>
+                </a:ln>
+                <a:solidFill>
+                  <a:schemeClr val="tx1"/>
+                </a:solidFill>
+                <a:effectLst/>
+                <a:latin typeface="Arial" panose="020B0604020202020204" pitchFamily="34" charset="0"/>
+              </a:rPr>
+              <a:t>.</a:t>
+            </a:r>
+          </a:p>
+        </p:txBody>
+      </p:sp>
+    </p:spTree>
+    <p:extLst>
+      <p:ext uri="{BB962C8B-B14F-4D97-AF65-F5344CB8AC3E}">
+        <p14:creationId xmlns:p14="http://schemas.microsoft.com/office/powerpoint/2010/main" val="3614817769"/>
       </p:ext>
     </p:extLst>
   </p:cSld>

</xml_diff>

<commit_message>
How to check role and permission at the blade
</commit_message>
<xml_diff>
--- a/.lessons/36 Packages Shopping Cart/2 Show dynamic products on frontend/1.pptx
+++ b/.lessons/36 Packages Shopping Cart/2 Show dynamic products on frontend/1.pptx
@@ -265,7 +265,7 @@
           <a:p>
             <a:fld id="{3E102D2E-813C-461C-9963-687A650C48C0}" type="datetimeFigureOut">
               <a:rPr lang="en-US" smtClean="0"/>
-              <a:t>6/18/2025</a:t>
+              <a:t>6/19/2025</a:t>
             </a:fld>
             <a:endParaRPr lang="en-US"/>
           </a:p>
@@ -463,7 +463,7 @@
           <a:p>
             <a:fld id="{3E102D2E-813C-461C-9963-687A650C48C0}" type="datetimeFigureOut">
               <a:rPr lang="en-US" smtClean="0"/>
-              <a:t>6/18/2025</a:t>
+              <a:t>6/19/2025</a:t>
             </a:fld>
             <a:endParaRPr lang="en-US"/>
           </a:p>
@@ -671,7 +671,7 @@
           <a:p>
             <a:fld id="{3E102D2E-813C-461C-9963-687A650C48C0}" type="datetimeFigureOut">
               <a:rPr lang="en-US" smtClean="0"/>
-              <a:t>6/18/2025</a:t>
+              <a:t>6/19/2025</a:t>
             </a:fld>
             <a:endParaRPr lang="en-US"/>
           </a:p>
@@ -869,7 +869,7 @@
           <a:p>
             <a:fld id="{3E102D2E-813C-461C-9963-687A650C48C0}" type="datetimeFigureOut">
               <a:rPr lang="en-US" smtClean="0"/>
-              <a:t>6/18/2025</a:t>
+              <a:t>6/19/2025</a:t>
             </a:fld>
             <a:endParaRPr lang="en-US"/>
           </a:p>
@@ -1144,7 +1144,7 @@
           <a:p>
             <a:fld id="{3E102D2E-813C-461C-9963-687A650C48C0}" type="datetimeFigureOut">
               <a:rPr lang="en-US" smtClean="0"/>
-              <a:t>6/18/2025</a:t>
+              <a:t>6/19/2025</a:t>
             </a:fld>
             <a:endParaRPr lang="en-US"/>
           </a:p>
@@ -1409,7 +1409,7 @@
           <a:p>
             <a:fld id="{3E102D2E-813C-461C-9963-687A650C48C0}" type="datetimeFigureOut">
               <a:rPr lang="en-US" smtClean="0"/>
-              <a:t>6/18/2025</a:t>
+              <a:t>6/19/2025</a:t>
             </a:fld>
             <a:endParaRPr lang="en-US"/>
           </a:p>
@@ -1821,7 +1821,7 @@
           <a:p>
             <a:fld id="{3E102D2E-813C-461C-9963-687A650C48C0}" type="datetimeFigureOut">
               <a:rPr lang="en-US" smtClean="0"/>
-              <a:t>6/18/2025</a:t>
+              <a:t>6/19/2025</a:t>
             </a:fld>
             <a:endParaRPr lang="en-US"/>
           </a:p>
@@ -1962,7 +1962,7 @@
           <a:p>
             <a:fld id="{3E102D2E-813C-461C-9963-687A650C48C0}" type="datetimeFigureOut">
               <a:rPr lang="en-US" smtClean="0"/>
-              <a:t>6/18/2025</a:t>
+              <a:t>6/19/2025</a:t>
             </a:fld>
             <a:endParaRPr lang="en-US"/>
           </a:p>
@@ -2075,7 +2075,7 @@
           <a:p>
             <a:fld id="{3E102D2E-813C-461C-9963-687A650C48C0}" type="datetimeFigureOut">
               <a:rPr lang="en-US" smtClean="0"/>
-              <a:t>6/18/2025</a:t>
+              <a:t>6/19/2025</a:t>
             </a:fld>
             <a:endParaRPr lang="en-US"/>
           </a:p>
@@ -2386,7 +2386,7 @@
           <a:p>
             <a:fld id="{3E102D2E-813C-461C-9963-687A650C48C0}" type="datetimeFigureOut">
               <a:rPr lang="en-US" smtClean="0"/>
-              <a:t>6/18/2025</a:t>
+              <a:t>6/19/2025</a:t>
             </a:fld>
             <a:endParaRPr lang="en-US"/>
           </a:p>
@@ -2674,7 +2674,7 @@
           <a:p>
             <a:fld id="{3E102D2E-813C-461C-9963-687A650C48C0}" type="datetimeFigureOut">
               <a:rPr lang="en-US" smtClean="0"/>
-              <a:t>6/18/2025</a:t>
+              <a:t>6/19/2025</a:t>
             </a:fld>
             <a:endParaRPr lang="en-US"/>
           </a:p>
@@ -2915,7 +2915,7 @@
           <a:p>
             <a:fld id="{3E102D2E-813C-461C-9963-687A650C48C0}" type="datetimeFigureOut">
               <a:rPr lang="en-US" smtClean="0"/>
-              <a:t>6/18/2025</a:t>
+              <a:t>6/19/2025</a:t>
             </a:fld>
             <a:endParaRPr lang="en-US"/>
           </a:p>
@@ -3548,7 +3548,33 @@
                 <a:effectLst/>
                 <a:latin typeface="Arial" panose="020B0604020202020204" pitchFamily="34" charset="0"/>
               </a:rPr>
-              <a:t>Məıumatlar DB -dən çəkərək şablona göndəririk.</a:t>
+              <a:t>Məıumatlar </a:t>
+            </a:r>
+            <a:r>
+              <a:rPr kumimoji="0" lang="az-Latn-AZ" altLang="en-US" sz="1300" b="1" i="0" u="none" strike="noStrike" cap="none" normalizeH="0" baseline="0">
+                <a:ln>
+                  <a:noFill/>
+                </a:ln>
+                <a:solidFill>
+                  <a:schemeClr val="tx1"/>
+                </a:solidFill>
+                <a:effectLst/>
+                <a:latin typeface="Arial" panose="020B0604020202020204" pitchFamily="34" charset="0"/>
+              </a:rPr>
+              <a:t>DB</a:t>
+            </a:r>
+            <a:r>
+              <a:rPr kumimoji="0" lang="az-Latn-AZ" altLang="en-US" sz="1300" b="0" i="0" u="none" strike="noStrike" cap="none" normalizeH="0" baseline="0">
+                <a:ln>
+                  <a:noFill/>
+                </a:ln>
+                <a:solidFill>
+                  <a:schemeClr val="tx1"/>
+                </a:solidFill>
+                <a:effectLst/>
+                <a:latin typeface="Arial" panose="020B0604020202020204" pitchFamily="34" charset="0"/>
+              </a:rPr>
+              <a:t> -dən çəkərək şablona göndəririk.</a:t>
             </a:r>
             <a:endParaRPr kumimoji="0" lang="en-US" altLang="en-US" sz="1300" b="0" i="0" u="none" strike="noStrike" cap="none" normalizeH="0" baseline="0">
               <a:ln>
@@ -3679,6 +3705,36 @@
           </a:p>
         </p:txBody>
       </p:sp>
+      <p:pic>
+        <p:nvPicPr>
+          <p:cNvPr id="4" name="Picture 3">
+            <a:extLst>
+              <a:ext uri="{FF2B5EF4-FFF2-40B4-BE49-F238E27FC236}">
+                <a16:creationId xmlns:a16="http://schemas.microsoft.com/office/drawing/2014/main" id="{C7B48E1D-B8AC-11D7-0D9F-1D3FAFD383F5}"/>
+              </a:ext>
+            </a:extLst>
+          </p:cNvPr>
+          <p:cNvPicPr>
+            <a:picLocks noChangeAspect="1"/>
+          </p:cNvPicPr>
+          <p:nvPr/>
+        </p:nvPicPr>
+        <p:blipFill>
+          <a:blip r:embed="rId2"/>
+          <a:stretch>
+            <a:fillRect/>
+          </a:stretch>
+        </p:blipFill>
+        <p:spPr>
+          <a:xfrm>
+            <a:off x="322296" y="0"/>
+            <a:ext cx="11547408" cy="6858000"/>
+          </a:xfrm>
+          <a:prstGeom prst="rect">
+            <a:avLst/>
+          </a:prstGeom>
+        </p:spPr>
+      </p:pic>
     </p:spTree>
     <p:extLst>
       <p:ext uri="{BB962C8B-B14F-4D97-AF65-F5344CB8AC3E}">

</xml_diff>